<commit_message>
fix presentazione parte federico
</commit_message>
<xml_diff>
--- a/slides/SoSE-Employment-DaaS-EaaS.pptx
+++ b/slides/SoSE-Employment-DaaS-EaaS.pptx
@@ -721,6 +721,36 @@
           <a:bodyPr/>
           <a:lstStyle/>
           <a:p>
+            <a:pPr marL="0" marR="0" lvl="0" indent="0" algn="l" defTabSz="914400" rtl="0" eaLnBrk="1" fontAlgn="auto" latinLnBrk="0" hangingPunct="1">
+              <a:lnSpc>
+                <a:spcPct val="100000"/>
+              </a:lnSpc>
+              <a:spcBef>
+                <a:spcPts val="0"/>
+              </a:spcBef>
+              <a:spcAft>
+                <a:spcPts val="0"/>
+              </a:spcAft>
+              <a:buClrTx/>
+              <a:buSzTx/>
+              <a:buFontTx/>
+              <a:buNone/>
+              <a:tabLst/>
+              <a:defRPr/>
+            </a:pPr>
+            <a:r>
+              <a:rPr lang="en-US" dirty="0"/>
+              <a:t>Good morning everyone.</a:t>
+            </a:r>
+            <a:br>
+              <a:rPr lang="en-US" dirty="0"/>
+            </a:br>
+            <a:r>
+              <a:rPr lang="en-US" dirty="0"/>
+              <a:t>In this final part of the presentation, I would like to focus on the governance and reflection aspects of our project, especially the audit trail, the ethical decision process, and the main limitations of the system.</a:t>
+            </a:r>
+          </a:p>
+          <a:p>
             <a:endParaRPr lang="en-US" dirty="0"/>
           </a:p>
         </p:txBody>
@@ -805,6 +835,159 @@
           <a:bodyPr/>
           <a:lstStyle/>
           <a:p>
+            <a:r>
+              <a:rPr lang="en-US" dirty="0"/>
+              <a:t>One of the core ideas behind our EaaS module is accountability.</a:t>
+            </a:r>
+            <a:br>
+              <a:rPr lang="en-US" dirty="0"/>
+            </a:br>
+            <a:r>
+              <a:rPr lang="en-US" dirty="0"/>
+              <a:t>Every ethical evaluation performed by the system is fully tracked through an audit trail.</a:t>
+            </a:r>
+          </a:p>
+          <a:p>
+            <a:r>
+              <a:rPr lang="en-US" dirty="0"/>
+              <a:t>For each evaluation, the system stores a complete audit record containing:</a:t>
+            </a:r>
+          </a:p>
+          <a:p>
+            <a:r>
+              <a:rPr lang="en-US" dirty="0"/>
+              <a:t>a unique identifier, </a:t>
+            </a:r>
+          </a:p>
+          <a:p>
+            <a:r>
+              <a:rPr lang="en-US" dirty="0"/>
+              <a:t>a timestamp, </a:t>
+            </a:r>
+          </a:p>
+          <a:p>
+            <a:r>
+              <a:rPr lang="en-US" dirty="0"/>
+              <a:t>the original request, </a:t>
+            </a:r>
+          </a:p>
+          <a:p>
+            <a:r>
+              <a:rPr lang="en-US" dirty="0"/>
+              <a:t>the candidate and job data used during evaluation, </a:t>
+            </a:r>
+          </a:p>
+          <a:p>
+            <a:r>
+              <a:rPr lang="en-US" dirty="0"/>
+              <a:t>the final risk level, </a:t>
+            </a:r>
+          </a:p>
+          <a:p>
+            <a:r>
+              <a:rPr lang="en-US" dirty="0"/>
+              <a:t>the final decision, </a:t>
+            </a:r>
+          </a:p>
+          <a:p>
+            <a:r>
+              <a:rPr lang="en-US" dirty="0"/>
+              <a:t>and all evaluated policies. </a:t>
+            </a:r>
+          </a:p>
+          <a:p>
+            <a:r>
+              <a:rPr lang="en-US" dirty="0"/>
+              <a:t>This is important because it allows us to reconstruct every decision made by the system.</a:t>
+            </a:r>
+          </a:p>
+          <a:p>
+            <a:r>
+              <a:rPr lang="en-US" dirty="0"/>
+              <a:t>For example, if a recommendation is rejected, we can later verify:</a:t>
+            </a:r>
+          </a:p>
+          <a:p>
+            <a:r>
+              <a:rPr lang="en-US" dirty="0"/>
+              <a:t>who requested the evaluation, </a:t>
+            </a:r>
+          </a:p>
+          <a:p>
+            <a:r>
+              <a:rPr lang="en-US" dirty="0"/>
+              <a:t>which data was analyzed, </a:t>
+            </a:r>
+          </a:p>
+          <a:p>
+            <a:r>
+              <a:rPr lang="en-US" dirty="0"/>
+              <a:t>which ethical policies were triggered, </a:t>
+            </a:r>
+          </a:p>
+          <a:p>
+            <a:r>
+              <a:rPr lang="en-US" dirty="0"/>
+              <a:t>and why the system produced that result. </a:t>
+            </a:r>
+          </a:p>
+          <a:p>
+            <a:r>
+              <a:rPr lang="en-US" dirty="0"/>
+              <a:t>Another important aspect is provenance tracking.</a:t>
+            </a:r>
+          </a:p>
+          <a:p>
+            <a:r>
+              <a:rPr lang="en-US" dirty="0"/>
+              <a:t>The EaaS stores the real data fetched from the DaaS during the evaluation process.</a:t>
+            </a:r>
+            <a:br>
+              <a:rPr lang="en-US" dirty="0"/>
+            </a:br>
+            <a:r>
+              <a:rPr lang="en-US" dirty="0"/>
+              <a:t>This means that even if the dataset changes later, we still preserve the exact snapshot that was used when the decision was made.</a:t>
+            </a:r>
+          </a:p>
+          <a:p>
+            <a:r>
+              <a:rPr lang="en-US" dirty="0"/>
+              <a:t>This improves transparency and reproducibility, which are fundamental concepts in ethical and trustworthy systems.</a:t>
+            </a:r>
+          </a:p>
+          <a:p>
+            <a:r>
+              <a:rPr lang="en-US" dirty="0"/>
+              <a:t>The audit trail is persisted using the JSONL format, meaning one JSON object per line.</a:t>
+            </a:r>
+          </a:p>
+          <a:p>
+            <a:r>
+              <a:rPr lang="en-US" dirty="0"/>
+              <a:t>This creates an append-only history of evaluations.</a:t>
+            </a:r>
+          </a:p>
+          <a:p>
+            <a:r>
+              <a:rPr lang="en-US" dirty="0"/>
+              <a:t>Previous records are never modified or overwritten.</a:t>
+            </a:r>
+            <a:br>
+              <a:rPr lang="en-US" dirty="0"/>
+            </a:br>
+            <a:r>
+              <a:rPr lang="en-US" dirty="0"/>
+              <a:t>New evaluations are simply appended to the log.</a:t>
+            </a:r>
+          </a:p>
+          <a:p>
+            <a:r>
+              <a:rPr lang="en-US" dirty="0"/>
+              <a:t>This approach is commonly used in governance and compliance systems because it preserves historical evidence and improves traceability.</a:t>
+            </a:r>
+          </a:p>
+          <a:p>
             <a:endParaRPr lang="en-US" dirty="0"/>
           </a:p>
         </p:txBody>
@@ -889,6 +1072,18 @@
           <a:bodyPr/>
           <a:lstStyle/>
           <a:p>
+            <a:r>
+              <a:rPr lang="en-US" dirty="0"/>
+              <a:t>Regarding the ethical decision process itself, the EaaS evaluates all active policies and then aggregates the results.</a:t>
+            </a:r>
+          </a:p>
+          <a:p>
+            <a:r>
+              <a:rPr lang="en-US" dirty="0"/>
+              <a:t>If no policy is violated, the recommendation is accepted with a PROCEED decision and a LOW risk level.</a:t>
+            </a:r>
+          </a:p>
+          <a:p>
             <a:endParaRPr lang="en-US" dirty="0"/>
           </a:p>
         </p:txBody>
@@ -973,6 +1168,54 @@
           <a:bodyPr/>
           <a:lstStyle/>
           <a:p>
+            <a:r>
+              <a:rPr lang="en-US" dirty="0"/>
+              <a:t>Instead, if severe violations are detected, the recommendation may be rejected.</a:t>
+            </a:r>
+          </a:p>
+          <a:p>
+            <a:r>
+              <a:rPr lang="en-US" dirty="0"/>
+              <a:t>For example, in our second scenario, the offer contains an explicit age restriction and also comes from an untrusted source.</a:t>
+            </a:r>
+          </a:p>
+          <a:p>
+            <a:r>
+              <a:rPr lang="en-US" dirty="0"/>
+              <a:t>These elements trigger two different policies:</a:t>
+            </a:r>
+          </a:p>
+          <a:p>
+            <a:r>
+              <a:rPr lang="en-US" dirty="0"/>
+              <a:t>the discriminatory proxy policy, </a:t>
+            </a:r>
+          </a:p>
+          <a:p>
+            <a:r>
+              <a:rPr lang="en-US" dirty="0"/>
+              <a:t>and the provenance policy. </a:t>
+            </a:r>
+          </a:p>
+          <a:p>
+            <a:r>
+              <a:rPr lang="en-US" dirty="0"/>
+              <a:t>Because the discriminatory policy produces a CRITICAL severity finding, the final decision becomes REJECT.</a:t>
+            </a:r>
+          </a:p>
+          <a:p>
+            <a:r>
+              <a:rPr lang="en-US" dirty="0"/>
+              <a:t>However, an important clarification is that REJECT does not permanently remove the offer from the system.</a:t>
+            </a:r>
+          </a:p>
+          <a:p>
+            <a:r>
+              <a:rPr lang="en-US" dirty="0"/>
+              <a:t>The EaaS only blocks the automatic recommendation process.</a:t>
+            </a:r>
+          </a:p>
+          <a:p>
             <a:endParaRPr lang="en-US" dirty="0"/>
           </a:p>
         </p:txBody>
@@ -1141,6 +1384,174 @@
           <a:bodyPr/>
           <a:lstStyle/>
           <a:p>
+            <a:r>
+              <a:rPr lang="en-US" dirty="0"/>
+              <a:t>Human review is still required before taking permanent actions.</a:t>
+            </a:r>
+          </a:p>
+          <a:p>
+            <a:r>
+              <a:rPr lang="en-US" dirty="0"/>
+              <a:t>This leads to the critical reflection section of the project.</a:t>
+            </a:r>
+          </a:p>
+          <a:p>
+            <a:r>
+              <a:rPr lang="en-US" dirty="0"/>
+              <a:t>Our system has several important limitations.</a:t>
+            </a:r>
+          </a:p>
+          <a:p>
+            <a:r>
+              <a:rPr lang="en-US" dirty="0"/>
+              <a:t>First, it only detects explicit discriminatory fields such as:</a:t>
+            </a:r>
+          </a:p>
+          <a:p>
+            <a:r>
+              <a:rPr lang="en-US" dirty="0"/>
+              <a:t>age limits, </a:t>
+            </a:r>
+          </a:p>
+          <a:p>
+            <a:r>
+              <a:rPr lang="en-US" dirty="0"/>
+              <a:t>gender preferences, </a:t>
+            </a:r>
+          </a:p>
+          <a:p>
+            <a:r>
+              <a:rPr lang="en-US" dirty="0"/>
+              <a:t>and nationality requirements. </a:t>
+            </a:r>
+          </a:p>
+          <a:p>
+            <a:r>
+              <a:rPr lang="en-US" dirty="0"/>
+              <a:t>It does not detect indirect or subtle proxies such as:</a:t>
+            </a:r>
+          </a:p>
+          <a:p>
+            <a:r>
+              <a:rPr lang="en-US" dirty="0"/>
+              <a:t>postcode, </a:t>
+            </a:r>
+          </a:p>
+          <a:p>
+            <a:r>
+              <a:rPr lang="en-US" dirty="0"/>
+              <a:t>university, </a:t>
+            </a:r>
+          </a:p>
+          <a:p>
+            <a:r>
+              <a:rPr lang="en-US" dirty="0"/>
+              <a:t>names, </a:t>
+            </a:r>
+          </a:p>
+          <a:p>
+            <a:r>
+              <a:rPr lang="en-US" dirty="0"/>
+              <a:t>or employment gaps. </a:t>
+            </a:r>
+          </a:p>
+          <a:p>
+            <a:r>
+              <a:rPr lang="en-US" dirty="0"/>
+              <a:t>These forms of bias are much more difficult to identify and would require advanced statistical or machine learning techniques.</a:t>
+            </a:r>
+          </a:p>
+          <a:p>
+            <a:endParaRPr lang="en-US" dirty="0"/>
+          </a:p>
+          <a:p>
+            <a:endParaRPr lang="en-US" dirty="0"/>
+          </a:p>
+          <a:p>
+            <a:r>
+              <a:rPr lang="en-US" dirty="0"/>
+              <a:t>Another limitation is that the ethical logic is still implemented in Java code.</a:t>
+            </a:r>
+          </a:p>
+          <a:p>
+            <a:r>
+              <a:rPr lang="en-US" dirty="0"/>
+              <a:t>The JSON policy files contain metadata and configuration parameters, but the actual evaluation behavior is hardcoded.</a:t>
+            </a:r>
+          </a:p>
+          <a:p>
+            <a:r>
+              <a:rPr lang="en-US" dirty="0"/>
+              <a:t>As a consequence, modifying the behavior of the policies still requires developer intervention.</a:t>
+            </a:r>
+          </a:p>
+          <a:p>
+            <a:endParaRPr lang="en-US" dirty="0"/>
+          </a:p>
+          <a:p>
+            <a:endParaRPr lang="en-US" dirty="0"/>
+          </a:p>
+          <a:p>
+            <a:r>
+              <a:rPr lang="en-US" dirty="0"/>
+              <a:t>The system also does not compute aggregate fairness metrics over time.</a:t>
+            </a:r>
+          </a:p>
+          <a:p>
+            <a:r>
+              <a:rPr lang="en-US" dirty="0"/>
+              <a:t>Each recommendation is evaluated individually, but the platform cannot detect systemic disparities across demographic groups.</a:t>
+            </a:r>
+          </a:p>
+          <a:p>
+            <a:r>
+              <a:rPr lang="en-US" dirty="0"/>
+              <a:t>For example, it cannot determine whether a specific category of candidates consistently receives fewer recommendations than others.</a:t>
+            </a:r>
+          </a:p>
+          <a:p>
+            <a:endParaRPr lang="en-US" dirty="0"/>
+          </a:p>
+          <a:p>
+            <a:endParaRPr lang="en-US" dirty="0"/>
+          </a:p>
+          <a:p>
+            <a:r>
+              <a:rPr lang="en-US" dirty="0"/>
+              <a:t>Another limitation is that the dataset used in the project is synthetic.</a:t>
+            </a:r>
+          </a:p>
+          <a:p>
+            <a:r>
+              <a:rPr lang="en-US" dirty="0"/>
+              <a:t>In a real production environment, additional concerns would be necessary, including:</a:t>
+            </a:r>
+          </a:p>
+          <a:p>
+            <a:r>
+              <a:rPr lang="en-US" dirty="0"/>
+              <a:t>GDPR consent management, </a:t>
+            </a:r>
+          </a:p>
+          <a:p>
+            <a:r>
+              <a:rPr lang="en-US" dirty="0"/>
+              <a:t>encryption, </a:t>
+            </a:r>
+          </a:p>
+          <a:p>
+            <a:r>
+              <a:rPr lang="en-US" dirty="0"/>
+              <a:t>retention policies, </a:t>
+            </a:r>
+          </a:p>
+          <a:p>
+            <a:r>
+              <a:rPr lang="en-US" dirty="0"/>
+              <a:t>and right-to-explanation procedures.</a:t>
+            </a:r>
+          </a:p>
+          <a:p>
             <a:endParaRPr lang="en-US" dirty="0"/>
           </a:p>
         </p:txBody>
@@ -1308,6 +1719,132 @@
         <p:txBody>
           <a:bodyPr/>
           <a:lstStyle/>
+          <a:p>
+            <a:r>
+              <a:rPr lang="en-US" dirty="0"/>
+              <a:t>Finally, there are several decisions that we intentionally decided not to automate.</a:t>
+            </a:r>
+          </a:p>
+          <a:p>
+            <a:r>
+              <a:rPr lang="en-US" dirty="0"/>
+              <a:t>The platform does not perform final hiring decisions.</a:t>
+            </a:r>
+          </a:p>
+          <a:p>
+            <a:r>
+              <a:rPr lang="en-US" dirty="0"/>
+              <a:t>It only provides recommendations and ethical evaluations.</a:t>
+            </a:r>
+          </a:p>
+          <a:p>
+            <a:r>
+              <a:rPr lang="en-US" dirty="0"/>
+              <a:t>The final responsibility must always remain with human decision makers.</a:t>
+            </a:r>
+          </a:p>
+          <a:p>
+            <a:endParaRPr lang="en-US" dirty="0"/>
+          </a:p>
+          <a:p>
+            <a:r>
+              <a:rPr lang="en-US" dirty="0"/>
+              <a:t>Similarly, the system does not permanently exclude job offers automatically.</a:t>
+            </a:r>
+          </a:p>
+          <a:p>
+            <a:r>
+              <a:rPr lang="en-US" dirty="0"/>
+              <a:t>A REJECT decision only blocks automated recommendation flows until a human review is performed.</a:t>
+            </a:r>
+          </a:p>
+          <a:p>
+            <a:endParaRPr lang="en-US" dirty="0"/>
+          </a:p>
+          <a:p>
+            <a:r>
+              <a:rPr lang="en-US" dirty="0"/>
+              <a:t>The EaaS also cannot interpret complex legal contexts.</a:t>
+            </a:r>
+          </a:p>
+          <a:p>
+            <a:r>
+              <a:rPr lang="en-US" dirty="0"/>
+              <a:t>For instance, a nationality requirement may sometimes be discriminatory, but in other cases it could be legally justified due to national security regulations.</a:t>
+            </a:r>
+          </a:p>
+          <a:p>
+            <a:r>
+              <a:rPr lang="en-US" dirty="0"/>
+              <a:t>The system lacks the contextual understanding required for those situations, so escalation to human review is necessary.</a:t>
+            </a:r>
+          </a:p>
+          <a:p>
+            <a:endParaRPr lang="en-US" dirty="0"/>
+          </a:p>
+          <a:p>
+            <a:r>
+              <a:rPr lang="en-US" dirty="0"/>
+              <a:t>Finally, the platform does not evaluate soft skills or human qualities such as:</a:t>
+            </a:r>
+          </a:p>
+          <a:p>
+            <a:r>
+              <a:rPr lang="en-US" dirty="0"/>
+              <a:t>motivation, </a:t>
+            </a:r>
+          </a:p>
+          <a:p>
+            <a:r>
+              <a:rPr lang="en-US" dirty="0"/>
+              <a:t>communication, </a:t>
+            </a:r>
+          </a:p>
+          <a:p>
+            <a:r>
+              <a:rPr lang="en-US" dirty="0"/>
+              <a:t>leadership, </a:t>
+            </a:r>
+          </a:p>
+          <a:p>
+            <a:r>
+              <a:rPr lang="en-US" dirty="0"/>
+              <a:t>empathy, </a:t>
+            </a:r>
+          </a:p>
+          <a:p>
+            <a:r>
+              <a:rPr lang="en-US" dirty="0"/>
+              <a:t>or cultural fit. </a:t>
+            </a:r>
+          </a:p>
+          <a:p>
+            <a:r>
+              <a:rPr lang="en-US" dirty="0"/>
+              <a:t>Those dimensions remain outside the scope of our RDF model and should not be delegated to automated systems.</a:t>
+            </a:r>
+          </a:p>
+          <a:p>
+            <a:endParaRPr lang="en-US" dirty="0"/>
+          </a:p>
+          <a:p>
+            <a:r>
+              <a:rPr lang="en-US" dirty="0"/>
+              <a:t>So the key message of this project is that ethics should not be treated as a final checkbox added after development.</a:t>
+            </a:r>
+          </a:p>
+          <a:p>
+            <a:r>
+              <a:rPr lang="en-US" dirty="0"/>
+              <a:t>Instead, governance, transparency, auditing, and human oversight should be integrated directly into the architecture of the system itself.</a:t>
+            </a:r>
+          </a:p>
+          <a:p>
+            <a:r>
+              <a:rPr lang="en-US" dirty="0"/>
+              <a:t>Thank you.</a:t>
+            </a:r>
+          </a:p>
           <a:p>
             <a:endParaRPr lang="en-US" dirty="0"/>
           </a:p>
@@ -8223,7 +8760,7 @@
                 <a:ea typeface="Calibri" pitchFamily="34" charset="-122"/>
                 <a:cs typeface="Calibri" pitchFamily="34" charset="-120"/>
               </a:rPr>
-              <a:t>  Federico Ciccio Capricci</a:t>
+              <a:t>  Federico Capricci</a:t>
             </a:r>
             <a:endParaRPr lang="en-US" sz="1200" dirty="0"/>
           </a:p>
@@ -8534,26 +9071,24 @@
                 <a:ea typeface="Consolas" pitchFamily="34" charset="-122"/>
                 <a:cs typeface="Consolas" pitchFamily="34" charset="-120"/>
               </a:rPr>
-              <a:t>  "auditId": "audit-8f43...",</a:t>
-            </a:r>
-            <a:endParaRPr lang="en-US" sz="1050" dirty="0"/>
-          </a:p>
-          <a:p>
-            <a:pPr marL="0" indent="0">
-              <a:buNone/>
-            </a:pPr>
+              <a:t>  </a:t>
+            </a:r>
             <a:r>
               <a:rPr lang="en-US" sz="1050" dirty="0">
                 <a:solidFill>
-                  <a:srgbClr val="86EFAC"/>
+                  <a:srgbClr val="E482F4"/>
                 </a:solidFill>
                 <a:latin typeface="Consolas" pitchFamily="34" charset="0"/>
                 <a:ea typeface="Consolas" pitchFamily="34" charset="-122"/>
                 <a:cs typeface="Consolas" pitchFamily="34" charset="-120"/>
               </a:rPr>
-              <a:t>  "timestamp": "2026-05-19T08:07:50Z",</a:t>
-            </a:r>
-            <a:endParaRPr lang="en-US" sz="1050" dirty="0"/>
+              <a:t>"auditId": "audit-8f43...",</a:t>
+            </a:r>
+            <a:endParaRPr lang="en-US" sz="1050" dirty="0">
+              <a:solidFill>
+                <a:srgbClr val="E482F4"/>
+              </a:solidFill>
+            </a:endParaRPr>
           </a:p>
           <a:p>
             <a:pPr marL="0" indent="0">
@@ -8568,26 +9103,24 @@
                 <a:ea typeface="Consolas" pitchFamily="34" charset="-122"/>
                 <a:cs typeface="Consolas" pitchFamily="34" charset="-120"/>
               </a:rPr>
-              <a:t>  "request": { "candidateId": "cand-001",</a:t>
-            </a:r>
-            <a:endParaRPr lang="en-US" sz="1050" dirty="0"/>
-          </a:p>
-          <a:p>
-            <a:pPr marL="0" indent="0">
-              <a:buNone/>
-            </a:pPr>
+              <a:t>  </a:t>
+            </a:r>
             <a:r>
               <a:rPr lang="en-US" sz="1050" dirty="0">
                 <a:solidFill>
-                  <a:srgbClr val="86EFAC"/>
+                  <a:srgbClr val="E482F4"/>
                 </a:solidFill>
                 <a:latin typeface="Consolas" pitchFamily="34" charset="0"/>
                 <a:ea typeface="Consolas" pitchFamily="34" charset="-122"/>
                 <a:cs typeface="Consolas" pitchFamily="34" charset="-120"/>
               </a:rPr>
-              <a:t>               "jobId": "job-003" ... },</a:t>
-            </a:r>
-            <a:endParaRPr lang="en-US" sz="1050" dirty="0"/>
+              <a:t>"timestamp": "2026-05-19T08:07:50Z",</a:t>
+            </a:r>
+            <a:endParaRPr lang="en-US" sz="1050" dirty="0">
+              <a:solidFill>
+                <a:srgbClr val="E482F4"/>
+              </a:solidFill>
+            </a:endParaRPr>
           </a:p>
           <a:p>
             <a:pPr marL="0" indent="0">
@@ -8602,26 +9135,24 @@
                 <a:ea typeface="Consolas" pitchFamily="34" charset="-122"/>
                 <a:cs typeface="Consolas" pitchFamily="34" charset="-120"/>
               </a:rPr>
-              <a:t>  "evaluatedCandidate": { ... },</a:t>
-            </a:r>
-            <a:endParaRPr lang="en-US" sz="1050" dirty="0"/>
-          </a:p>
-          <a:p>
-            <a:pPr marL="0" indent="0">
-              <a:buNone/>
-            </a:pPr>
+              <a:t>  </a:t>
+            </a:r>
             <a:r>
               <a:rPr lang="en-US" sz="1050" dirty="0">
                 <a:solidFill>
-                  <a:srgbClr val="86EFAC"/>
+                  <a:srgbClr val="00B0F0"/>
                 </a:solidFill>
                 <a:latin typeface="Consolas" pitchFamily="34" charset="0"/>
                 <a:ea typeface="Consolas" pitchFamily="34" charset="-122"/>
                 <a:cs typeface="Consolas" pitchFamily="34" charset="-120"/>
               </a:rPr>
-              <a:t>  "evaluatedJob": { ... },</a:t>
-            </a:r>
-            <a:endParaRPr lang="en-US" sz="1050" dirty="0"/>
+              <a:t>"request": { "candidateId": "cand-001",</a:t>
+            </a:r>
+            <a:endParaRPr lang="en-US" sz="1050" dirty="0">
+              <a:solidFill>
+                <a:srgbClr val="00B0F0"/>
+              </a:solidFill>
+            </a:endParaRPr>
           </a:p>
           <a:p>
             <a:pPr marL="0" indent="0">
@@ -8630,15 +9161,19 @@
             <a:r>
               <a:rPr lang="en-US" sz="1050" dirty="0">
                 <a:solidFill>
-                  <a:srgbClr val="86EFAC"/>
+                  <a:srgbClr val="00B0F0"/>
                 </a:solidFill>
                 <a:latin typeface="Consolas" pitchFamily="34" charset="0"/>
                 <a:ea typeface="Consolas" pitchFamily="34" charset="-122"/>
                 <a:cs typeface="Consolas" pitchFamily="34" charset="-120"/>
               </a:rPr>
-              <a:t>  "riskLevel": "CRITICAL",</a:t>
-            </a:r>
-            <a:endParaRPr lang="en-US" sz="1050" dirty="0"/>
+              <a:t>               "jobId": "job-003" ... },</a:t>
+            </a:r>
+            <a:endParaRPr lang="en-US" sz="1050" dirty="0">
+              <a:solidFill>
+                <a:srgbClr val="00B0F0"/>
+              </a:solidFill>
+            </a:endParaRPr>
           </a:p>
           <a:p>
             <a:pPr marL="0" indent="0">
@@ -8653,26 +9188,24 @@
                 <a:ea typeface="Consolas" pitchFamily="34" charset="-122"/>
                 <a:cs typeface="Consolas" pitchFamily="34" charset="-120"/>
               </a:rPr>
-              <a:t>  "decision": "REJECT",</a:t>
-            </a:r>
-            <a:endParaRPr lang="en-US" sz="1050" dirty="0"/>
-          </a:p>
-          <a:p>
-            <a:pPr marL="0" indent="0">
-              <a:buNone/>
-            </a:pPr>
+              <a:t>  </a:t>
+            </a:r>
             <a:r>
               <a:rPr lang="en-US" sz="1050" dirty="0">
                 <a:solidFill>
-                  <a:srgbClr val="86EFAC"/>
+                  <a:srgbClr val="FFFF00"/>
                 </a:solidFill>
                 <a:latin typeface="Consolas" pitchFamily="34" charset="0"/>
                 <a:ea typeface="Consolas" pitchFamily="34" charset="-122"/>
                 <a:cs typeface="Consolas" pitchFamily="34" charset="-120"/>
               </a:rPr>
-              <a:t>  "findings": [ { ... } ],</a:t>
-            </a:r>
-            <a:endParaRPr lang="en-US" sz="1050" dirty="0"/>
+              <a:t>"evaluatedCandidate": { ... },</a:t>
+            </a:r>
+            <a:endParaRPr lang="en-US" sz="1050" dirty="0">
+              <a:solidFill>
+                <a:srgbClr val="FFFF00"/>
+              </a:solidFill>
+            </a:endParaRPr>
           </a:p>
           <a:p>
             <a:pPr marL="0" indent="0">
@@ -8681,15 +9214,19 @@
             <a:r>
               <a:rPr lang="en-US" sz="1050" dirty="0">
                 <a:solidFill>
-                  <a:srgbClr val="86EFAC"/>
+                  <a:srgbClr val="FFFF00"/>
                 </a:solidFill>
                 <a:latin typeface="Consolas" pitchFamily="34" charset="0"/>
                 <a:ea typeface="Consolas" pitchFamily="34" charset="-122"/>
                 <a:cs typeface="Consolas" pitchFamily="34" charset="-120"/>
               </a:rPr>
-              <a:t>  "appliedPolicies": [</a:t>
-            </a:r>
-            <a:endParaRPr lang="en-US" sz="1050" dirty="0"/>
+              <a:t>  "evaluatedJob": { ... },</a:t>
+            </a:r>
+            <a:endParaRPr lang="en-US" sz="1050" dirty="0">
+              <a:solidFill>
+                <a:srgbClr val="FFFF00"/>
+              </a:solidFill>
+            </a:endParaRPr>
           </a:p>
           <a:p>
             <a:pPr marL="0" indent="0">
@@ -8704,7 +9241,7 @@
                 <a:ea typeface="Consolas" pitchFamily="34" charset="-122"/>
                 <a:cs typeface="Consolas" pitchFamily="34" charset="-120"/>
               </a:rPr>
-              <a:t>    "P-ACC-003", "P-DISCR-001",</a:t>
+              <a:t>  "riskLevel": "CRITICAL",</a:t>
             </a:r>
             <a:endParaRPr lang="en-US" sz="1050" dirty="0"/>
           </a:p>
@@ -8721,26 +9258,24 @@
                 <a:ea typeface="Consolas" pitchFamily="34" charset="-122"/>
                 <a:cs typeface="Consolas" pitchFamily="34" charset="-120"/>
               </a:rPr>
-              <a:t>    "P-PROV-002", "P-TRANS-004"</a:t>
-            </a:r>
-            <a:endParaRPr lang="en-US" sz="1050" dirty="0"/>
-          </a:p>
-          <a:p>
-            <a:pPr marL="0" indent="0">
-              <a:buNone/>
-            </a:pPr>
+              <a:t>  </a:t>
+            </a:r>
             <a:r>
               <a:rPr lang="en-US" sz="1050" dirty="0">
                 <a:solidFill>
-                  <a:srgbClr val="86EFAC"/>
+                  <a:srgbClr val="FF0000"/>
                 </a:solidFill>
                 <a:latin typeface="Consolas" pitchFamily="34" charset="0"/>
                 <a:ea typeface="Consolas" pitchFamily="34" charset="-122"/>
                 <a:cs typeface="Consolas" pitchFamily="34" charset="-120"/>
               </a:rPr>
-              <a:t>  ]</a:t>
-            </a:r>
-            <a:endParaRPr lang="en-US" sz="1050" dirty="0"/>
+              <a:t>"decision": "REJECT",</a:t>
+            </a:r>
+            <a:endParaRPr lang="en-US" sz="1050" dirty="0">
+              <a:solidFill>
+                <a:srgbClr val="FF0000"/>
+              </a:solidFill>
+            </a:endParaRPr>
           </a:p>
           <a:p>
             <a:pPr marL="0" indent="0">
@@ -8755,6 +9290,106 @@
                 <a:ea typeface="Consolas" pitchFamily="34" charset="-122"/>
                 <a:cs typeface="Consolas" pitchFamily="34" charset="-120"/>
               </a:rPr>
+              <a:t>  </a:t>
+            </a:r>
+            <a:r>
+              <a:rPr lang="en-US" sz="1050" dirty="0">
+                <a:solidFill>
+                  <a:srgbClr val="FF0000"/>
+                </a:solidFill>
+                <a:latin typeface="Consolas" pitchFamily="34" charset="0"/>
+                <a:ea typeface="Consolas" pitchFamily="34" charset="-122"/>
+                <a:cs typeface="Consolas" pitchFamily="34" charset="-120"/>
+              </a:rPr>
+              <a:t>"findings": [ { ... } ],</a:t>
+            </a:r>
+            <a:endParaRPr lang="en-US" sz="1050" dirty="0">
+              <a:solidFill>
+                <a:srgbClr val="FF0000"/>
+              </a:solidFill>
+            </a:endParaRPr>
+          </a:p>
+          <a:p>
+            <a:pPr marL="0" indent="0">
+              <a:buNone/>
+            </a:pPr>
+            <a:r>
+              <a:rPr lang="en-US" sz="1050" dirty="0">
+                <a:solidFill>
+                  <a:srgbClr val="86EFAC"/>
+                </a:solidFill>
+                <a:latin typeface="Consolas" pitchFamily="34" charset="0"/>
+                <a:ea typeface="Consolas" pitchFamily="34" charset="-122"/>
+                <a:cs typeface="Consolas" pitchFamily="34" charset="-120"/>
+              </a:rPr>
+              <a:t>  "appliedPolicies": [</a:t>
+            </a:r>
+            <a:endParaRPr lang="en-US" sz="1050" dirty="0"/>
+          </a:p>
+          <a:p>
+            <a:pPr marL="0" indent="0">
+              <a:buNone/>
+            </a:pPr>
+            <a:r>
+              <a:rPr lang="en-US" sz="1050" dirty="0">
+                <a:solidFill>
+                  <a:srgbClr val="86EFAC"/>
+                </a:solidFill>
+                <a:latin typeface="Consolas" pitchFamily="34" charset="0"/>
+                <a:ea typeface="Consolas" pitchFamily="34" charset="-122"/>
+                <a:cs typeface="Consolas" pitchFamily="34" charset="-120"/>
+              </a:rPr>
+              <a:t>    "P-ACC-003", "P-DISCR-001",</a:t>
+            </a:r>
+            <a:endParaRPr lang="en-US" sz="1050" dirty="0"/>
+          </a:p>
+          <a:p>
+            <a:pPr marL="0" indent="0">
+              <a:buNone/>
+            </a:pPr>
+            <a:r>
+              <a:rPr lang="en-US" sz="1050" dirty="0">
+                <a:solidFill>
+                  <a:srgbClr val="86EFAC"/>
+                </a:solidFill>
+                <a:latin typeface="Consolas" pitchFamily="34" charset="0"/>
+                <a:ea typeface="Consolas" pitchFamily="34" charset="-122"/>
+                <a:cs typeface="Consolas" pitchFamily="34" charset="-120"/>
+              </a:rPr>
+              <a:t>    "P-PROV-002", "P-TRANS-004"</a:t>
+            </a:r>
+            <a:endParaRPr lang="en-US" sz="1050" dirty="0"/>
+          </a:p>
+          <a:p>
+            <a:pPr marL="0" indent="0">
+              <a:buNone/>
+            </a:pPr>
+            <a:r>
+              <a:rPr lang="en-US" sz="1050" dirty="0">
+                <a:solidFill>
+                  <a:srgbClr val="86EFAC"/>
+                </a:solidFill>
+                <a:latin typeface="Consolas" pitchFamily="34" charset="0"/>
+                <a:ea typeface="Consolas" pitchFamily="34" charset="-122"/>
+                <a:cs typeface="Consolas" pitchFamily="34" charset="-120"/>
+              </a:rPr>
+              <a:t>  ]</a:t>
+            </a:r>
+            <a:endParaRPr lang="en-US" sz="1050" dirty="0"/>
+          </a:p>
+          <a:p>
+            <a:pPr marL="0" indent="0">
+              <a:buNone/>
+            </a:pPr>
+            <a:r>
+              <a:rPr lang="en-US" sz="1050" dirty="0">
+                <a:solidFill>
+                  <a:srgbClr val="86EFAC"/>
+                </a:solidFill>
+                <a:latin typeface="Consolas" pitchFamily="34" charset="0"/>
+                <a:ea typeface="Consolas" pitchFamily="34" charset="-122"/>
+                <a:cs typeface="Consolas" pitchFamily="34" charset="-120"/>
+              </a:rPr>
               <a:t>}</a:t>
             </a:r>
             <a:endParaRPr lang="en-US" sz="1050" dirty="0"/>
@@ -8769,7 +9404,7 @@
         </p:nvSpPr>
         <p:spPr>
           <a:xfrm>
-            <a:off x="5394960" y="1463040"/>
+            <a:off x="5394960" y="1663931"/>
             <a:ext cx="457200" cy="0"/>
           </a:xfrm>
           <a:prstGeom prst="line">
@@ -8838,7 +9473,7 @@
         </p:nvSpPr>
         <p:spPr>
           <a:xfrm>
-            <a:off x="5394960" y="1874520"/>
+            <a:off x="5394960" y="1828800"/>
             <a:ext cx="457200" cy="0"/>
           </a:xfrm>
           <a:prstGeom prst="line">
@@ -8868,7 +9503,7 @@
         </p:nvSpPr>
         <p:spPr>
           <a:xfrm>
-            <a:off x="5943600" y="1828800"/>
+            <a:off x="5943600" y="1586484"/>
             <a:ext cx="2834640" cy="457200"/>
           </a:xfrm>
           <a:prstGeom prst="rect">
@@ -8907,7 +9542,7 @@
         </p:nvSpPr>
         <p:spPr>
           <a:xfrm>
-            <a:off x="5394960" y="2194560"/>
+            <a:off x="5394960" y="2043684"/>
             <a:ext cx="457200" cy="0"/>
           </a:xfrm>
           <a:prstGeom prst="line">
@@ -8937,7 +9572,7 @@
         </p:nvSpPr>
         <p:spPr>
           <a:xfrm>
-            <a:off x="5943600" y="2148840"/>
+            <a:off x="5943600" y="1828800"/>
             <a:ext cx="2834640" cy="457200"/>
           </a:xfrm>
           <a:prstGeom prst="rect">
@@ -8976,20 +9611,36 @@
         </p:nvSpPr>
         <p:spPr>
           <a:xfrm>
-            <a:off x="5394960" y="2514600"/>
+            <a:off x="5394960" y="2403764"/>
             <a:ext cx="457200" cy="0"/>
           </a:xfrm>
           <a:prstGeom prst="line">
             <a:avLst/>
           </a:prstGeom>
-          <a:noFill/>
-          <a:ln w="12700">
+          <a:ln w="19050" cap="flat" cmpd="sng" algn="ctr">
             <a:solidFill>
-              <a:srgbClr val="2C5FDC"/>
+              <a:schemeClr val="accent4"/>
             </a:solidFill>
             <a:prstDash val="dash"/>
+            <a:round/>
+            <a:headEnd type="none" w="med" len="med"/>
+            <a:tailEnd type="none" w="med" len="med"/>
           </a:ln>
         </p:spPr>
+        <p:style>
+          <a:lnRef idx="0">
+            <a:scrgbClr r="0" g="0" b="0"/>
+          </a:lnRef>
+          <a:fillRef idx="0">
+            <a:scrgbClr r="0" g="0" b="0"/>
+          </a:fillRef>
+          <a:effectRef idx="0">
+            <a:scrgbClr r="0" g="0" b="0"/>
+          </a:effectRef>
+          <a:fontRef idx="minor">
+            <a:schemeClr val="tx1"/>
+          </a:fontRef>
+        </p:style>
         <p:txBody>
           <a:bodyPr/>
           <a:lstStyle/>
@@ -9006,7 +9657,7 @@
         </p:nvSpPr>
         <p:spPr>
           <a:xfrm>
-            <a:off x="5943600" y="2468880"/>
+            <a:off x="5943600" y="2180843"/>
             <a:ext cx="2834640" cy="457200"/>
           </a:xfrm>
           <a:prstGeom prst="rect">
@@ -9025,7 +9676,7 @@
             <a:r>
               <a:rPr lang="en-US" sz="1000" dirty="0">
                 <a:solidFill>
-                  <a:srgbClr val="2C5FDC"/>
+                  <a:srgbClr val="FFC000"/>
                 </a:solidFill>
                 <a:latin typeface="Calibri" pitchFamily="34" charset="0"/>
                 <a:ea typeface="Calibri" pitchFamily="34" charset="-122"/>
@@ -9033,7 +9684,11 @@
               </a:rPr>
               <a:t>Real data fetched from DaaS</a:t>
             </a:r>
-            <a:endParaRPr lang="en-US" sz="1000" dirty="0"/>
+            <a:endParaRPr lang="en-US" sz="1000" dirty="0">
+              <a:solidFill>
+                <a:srgbClr val="FFC000"/>
+              </a:solidFill>
+            </a:endParaRPr>
           </a:p>
           <a:p>
             <a:pPr marL="0" indent="0">
@@ -9042,15 +9697,19 @@
             <a:r>
               <a:rPr lang="en-US" sz="1000" dirty="0">
                 <a:solidFill>
-                  <a:srgbClr val="2C5FDC"/>
-                </a:solidFill>
-                <a:latin typeface="Calibri" pitchFamily="34" charset="0"/>
-                <a:ea typeface="Calibri" pitchFamily="34" charset="-122"/>
-                <a:cs typeface="Calibri" pitchFamily="34" charset="-120"/>
-              </a:rPr>
-              <a:t>→ provenance tracked</a:t>
-            </a:r>
-            <a:endParaRPr lang="en-US" sz="1000" dirty="0"/>
+                  <a:srgbClr val="FFC000"/>
+                </a:solidFill>
+                <a:latin typeface="Calibri" pitchFamily="34" charset="0"/>
+                <a:ea typeface="Calibri" pitchFamily="34" charset="-122"/>
+                <a:cs typeface="Calibri" pitchFamily="34" charset="-120"/>
+              </a:rPr>
+              <a:t>provenance tracked</a:t>
+            </a:r>
+            <a:endParaRPr lang="en-US" sz="1000" dirty="0">
+              <a:solidFill>
+                <a:srgbClr val="FFC000"/>
+              </a:solidFill>
+            </a:endParaRPr>
           </a:p>
         </p:txBody>
       </p:sp>
@@ -9062,7 +9721,7 @@
         </p:nvSpPr>
         <p:spPr>
           <a:xfrm>
-            <a:off x="5394960" y="3291840"/>
+            <a:off x="5386647" y="2876203"/>
             <a:ext cx="457200" cy="0"/>
           </a:xfrm>
           <a:prstGeom prst="line">
@@ -9092,7 +9751,7 @@
         </p:nvSpPr>
         <p:spPr>
           <a:xfrm>
-            <a:off x="5943600" y="3246120"/>
+            <a:off x="5943600" y="2648989"/>
             <a:ext cx="2834640" cy="457200"/>
           </a:xfrm>
           <a:prstGeom prst="rect">
@@ -9131,7 +9790,7 @@
         </p:nvSpPr>
         <p:spPr>
           <a:xfrm>
-            <a:off x="5394960" y="3840480"/>
+            <a:off x="5386647" y="3272443"/>
             <a:ext cx="457200" cy="0"/>
           </a:xfrm>
           <a:prstGeom prst="line">
@@ -9161,7 +9820,7 @@
         </p:nvSpPr>
         <p:spPr>
           <a:xfrm>
-            <a:off x="5669280" y="3886200"/>
+            <a:off x="5943600" y="3056382"/>
             <a:ext cx="2834640" cy="457200"/>
           </a:xfrm>
           <a:prstGeom prst="rect">

</xml_diff>